<commit_message>
Light-only everywhere; rename spec->specs; deck light-first
- All communication surfaces are now light-only: removed dark-mode CSS and
  theme toggles from the site, the OpenSpec review page, the brand guides,
  and the Foundation page (Direction A = on light).
- Rename the spec section: served at /specs/ (nav 'Specs', build_review
  outputs docs/specs/); old docs/spec removed.
- Deck reworked light-first: title and closing slides on white (charcoal +
  teal + mark), spine box on a light surface. Regenerated pptx + pdf.
- Removed the superseded dark HTML deck (timepie-forum.html); the pptx is
  canonical. (favicon stays theme-adaptive for tab legibility.)

Co-Authored-By: Claude Opus 4.8 <noreply@anthropic.com>
</commit_message>
<xml_diff>
--- a/docs/presentation/biohackit-deck.pptx
+++ b/docs/presentation/biohackit-deck.pptx
@@ -2558,7 +2558,7 @@
     <p:bg>
       <p:bgPr>
         <a:solidFill>
-          <a:srgbClr val="25292C"/>
+          <a:srgbClr val="FFFFFF"/>
         </a:solidFill>
       </p:bgPr>
     </p:bg>
@@ -2603,7 +2603,7 @@
             <a:r>
               <a:rPr lang="en-US" sz="1250" b="1" spc="320" kern="0" dirty="0">
                 <a:solidFill>
-                  <a:srgbClr val="33C7B8"/>
+                  <a:srgbClr val="0C877A"/>
                 </a:solidFill>
                 <a:latin typeface="Jost" pitchFamily="34" charset="0"/>
                 <a:ea typeface="Jost" pitchFamily="34" charset="-122"/>
@@ -2642,7 +2642,7 @@
             <a:r>
               <a:rPr lang="en-US" sz="8800" spc="100" kern="0" dirty="0">
                 <a:solidFill>
-                  <a:srgbClr val="FFFFFF"/>
+                  <a:srgbClr val="25292C"/>
                 </a:solidFill>
                 <a:latin typeface="Jost" pitchFamily="34" charset="0"/>
                 <a:ea typeface="Jost" pitchFamily="34" charset="-122"/>
@@ -2671,11 +2671,11 @@
             </a:avLst>
           </a:prstGeom>
           <a:solidFill>
-            <a:srgbClr val="FFFFFF"/>
+            <a:srgbClr val="25292C"/>
           </a:solidFill>
           <a:ln w="3175">
             <a:solidFill>
-              <a:srgbClr val="FFFFFF"/>
+              <a:srgbClr val="25292C"/>
             </a:solidFill>
             <a:prstDash val="solid"/>
           </a:ln>
@@ -2708,7 +2708,7 @@
             <a:r>
               <a:rPr lang="en-US" sz="1500" b="1" spc="600" kern="0" dirty="0">
                 <a:solidFill>
-                  <a:srgbClr val="FFFFFF"/>
+                  <a:srgbClr val="25292C"/>
                 </a:solidFill>
                 <a:latin typeface="Jost" pitchFamily="34" charset="0"/>
                 <a:ea typeface="Jost" pitchFamily="34" charset="-122"/>
@@ -2747,7 +2747,7 @@
             <a:r>
               <a:rPr lang="en-US" sz="3000" dirty="0">
                 <a:solidFill>
-                  <a:srgbClr val="AEB9BC"/>
+                  <a:srgbClr val="59636A"/>
                 </a:solidFill>
                 <a:latin typeface="Jost" pitchFamily="34" charset="0"/>
                 <a:ea typeface="Jost" pitchFamily="34" charset="-122"/>
@@ -2789,7 +2789,7 @@
             <a:r>
               <a:rPr lang="en-US" sz="1500" dirty="0">
                 <a:solidFill>
-                  <a:srgbClr val="9AA5A9"/>
+                  <a:srgbClr val="59636A"/>
                 </a:solidFill>
                 <a:latin typeface="Arial" pitchFamily="34" charset="0"/>
                 <a:ea typeface="Arial" pitchFamily="34" charset="-122"/>
@@ -2828,7 +2828,7 @@
             <a:r>
               <a:rPr lang="en-US" sz="1200" b="1" spc="200" kern="0" dirty="0">
                 <a:solidFill>
-                  <a:srgbClr val="6E7A7E"/>
+                  <a:srgbClr val="8B9398"/>
                 </a:solidFill>
                 <a:latin typeface="Jost" pitchFamily="34" charset="0"/>
                 <a:ea typeface="Jost" pitchFamily="34" charset="-122"/>
@@ -2855,11 +2855,11 @@
             <a:avLst/>
           </a:prstGeom>
           <a:solidFill>
-            <a:srgbClr val="25292C"/>
+            <a:srgbClr val="FFFFFF"/>
           </a:solidFill>
           <a:ln w="146304">
             <a:solidFill>
-              <a:srgbClr val="FFFFFF"/>
+              <a:srgbClr val="25292C"/>
             </a:solidFill>
             <a:prstDash val="solid"/>
           </a:ln>
@@ -2882,11 +2882,11 @@
             </a:avLst>
           </a:prstGeom>
           <a:solidFill>
-            <a:srgbClr val="33C7B8"/>
+            <a:srgbClr val="0C877A"/>
           </a:solidFill>
           <a:ln w="3175">
             <a:solidFill>
-              <a:srgbClr val="33C7B8"/>
+              <a:srgbClr val="0C877A"/>
             </a:solidFill>
             <a:prstDash val="solid"/>
           </a:ln>
@@ -5840,7 +5840,7 @@
     <p:bg>
       <p:bgPr>
         <a:solidFill>
-          <a:srgbClr val="25292C"/>
+          <a:srgbClr val="FFFFFF"/>
         </a:solidFill>
       </p:bgPr>
     </p:bg>
@@ -5885,7 +5885,7 @@
             <a:r>
               <a:rPr lang="en-US" sz="1250" b="1" spc="320" kern="0" dirty="0">
                 <a:solidFill>
-                  <a:srgbClr val="33C7B8"/>
+                  <a:srgbClr val="0C877A"/>
                 </a:solidFill>
                 <a:latin typeface="Jost" pitchFamily="34" charset="0"/>
                 <a:ea typeface="Jost" pitchFamily="34" charset="-122"/>
@@ -5927,7 +5927,7 @@
             <a:r>
               <a:rPr lang="en-US" sz="4000" dirty="0">
                 <a:solidFill>
-                  <a:srgbClr val="FFFFFF"/>
+                  <a:srgbClr val="25292C"/>
                 </a:solidFill>
                 <a:latin typeface="Jost" pitchFamily="34" charset="0"/>
                 <a:ea typeface="Jost" pitchFamily="34" charset="-122"/>
@@ -5944,7 +5944,7 @@
             <a:r>
               <a:rPr lang="en-US" sz="4000" dirty="0">
                 <a:solidFill>
-                  <a:srgbClr val="33C7B8"/>
+                  <a:srgbClr val="0C877A"/>
                 </a:solidFill>
                 <a:latin typeface="Jost" pitchFamily="34" charset="0"/>
                 <a:ea typeface="Jost" pitchFamily="34" charset="-122"/>
@@ -5983,7 +5983,7 @@
             <a:r>
               <a:rPr lang="en-US" sz="3200" dirty="0">
                 <a:solidFill>
-                  <a:srgbClr val="AEB9BC"/>
+                  <a:srgbClr val="59636A"/>
                 </a:solidFill>
                 <a:latin typeface="Jost" pitchFamily="34" charset="0"/>
                 <a:ea typeface="Jost" pitchFamily="34" charset="-122"/>
@@ -6025,7 +6025,7 @@
             <a:r>
               <a:rPr lang="en-US" sz="1500" dirty="0">
                 <a:solidFill>
-                  <a:srgbClr val="9AA5A9"/>
+                  <a:srgbClr val="59636A"/>
                 </a:solidFill>
                 <a:latin typeface="Arial" pitchFamily="34" charset="0"/>
                 <a:ea typeface="Arial" pitchFamily="34" charset="-122"/>
@@ -6064,7 +6064,7 @@
             <a:r>
               <a:rPr lang="en-US" sz="2600" spc="100" kern="0" dirty="0">
                 <a:solidFill>
-                  <a:srgbClr val="FFFFFF"/>
+                  <a:srgbClr val="25292C"/>
                 </a:solidFill>
                 <a:latin typeface="Jost" pitchFamily="34" charset="0"/>
                 <a:ea typeface="Jost" pitchFamily="34" charset="-122"/>
@@ -6093,11 +6093,11 @@
             </a:avLst>
           </a:prstGeom>
           <a:solidFill>
-            <a:srgbClr val="FFFFFF"/>
+            <a:srgbClr val="25292C"/>
           </a:solidFill>
           <a:ln w="3175">
             <a:solidFill>
-              <a:srgbClr val="FFFFFF"/>
+              <a:srgbClr val="25292C"/>
             </a:solidFill>
             <a:prstDash val="solid"/>
           </a:ln>
@@ -6130,7 +6130,7 @@
             <a:r>
               <a:rPr lang="en-US" sz="1200" b="1" spc="300" kern="0" dirty="0">
                 <a:solidFill>
-                  <a:srgbClr val="9AA5A9"/>
+                  <a:srgbClr val="8B9398"/>
                 </a:solidFill>
                 <a:latin typeface="Jost" pitchFamily="34" charset="0"/>
                 <a:ea typeface="Jost" pitchFamily="34" charset="-122"/>
@@ -6157,11 +6157,11 @@
             <a:avLst/>
           </a:prstGeom>
           <a:solidFill>
-            <a:srgbClr val="25292C"/>
+            <a:srgbClr val="FFFFFF"/>
           </a:solidFill>
           <a:ln w="138989">
             <a:solidFill>
-              <a:srgbClr val="FFFFFF"/>
+              <a:srgbClr val="25292C"/>
             </a:solidFill>
             <a:prstDash val="solid"/>
           </a:ln>
@@ -6184,11 +6184,11 @@
             </a:avLst>
           </a:prstGeom>
           <a:solidFill>
-            <a:srgbClr val="33C7B8"/>
+            <a:srgbClr val="0C877A"/>
           </a:solidFill>
           <a:ln w="3175">
             <a:solidFill>
-              <a:srgbClr val="33C7B8"/>
+              <a:srgbClr val="0C877A"/>
             </a:solidFill>
             <a:prstDash val="solid"/>
           </a:ln>
@@ -9412,11 +9412,11 @@
             </a:avLst>
           </a:prstGeom>
           <a:solidFill>
-            <a:srgbClr val="25292C"/>
+            <a:srgbClr val="F1F4F3"/>
           </a:solidFill>
           <a:ln w="12700">
             <a:solidFill>
-              <a:srgbClr val="25292C"/>
+              <a:srgbClr val="DDE3E1"/>
             </a:solidFill>
             <a:prstDash val="solid"/>
           </a:ln>
@@ -9449,7 +9449,7 @@
             <a:r>
               <a:rPr lang="en-US" sz="1900" dirty="0">
                 <a:solidFill>
-                  <a:srgbClr val="FFFFFF"/>
+                  <a:srgbClr val="25292C"/>
                 </a:solidFill>
                 <a:latin typeface="Jost" pitchFamily="34" charset="0"/>
                 <a:ea typeface="Jost" pitchFamily="34" charset="-122"/>
@@ -9488,7 +9488,7 @@
             <a:r>
               <a:rPr lang="en-US" sz="1300" i="1" dirty="0">
                 <a:solidFill>
-                  <a:srgbClr val="AEB9BC"/>
+                  <a:srgbClr val="8B9398"/>
                 </a:solidFill>
                 <a:latin typeface="Arial" pitchFamily="34" charset="0"/>
                 <a:ea typeface="Arial" pitchFamily="34" charset="-122"/>

</xml_diff>

<commit_message>
Deck: event title + TimePie logo/dates; empty branded template; downloadable PNG logos
- Deck title slide: file title 'Biohack.it - An Open Laboratory for Longevity',
  2-line lockup (payoff), and PRESENTED AT: TimePie logo + 'September 12-13,
  2026 - Shanghai'. Deck pptx+pdf refreshed.
- New empty branded template (biohackit-template.pptx): title / section /
  cards / bullets / closing layouts with placeholders.
- Logos now exported as PNG (+ SVG) in brand/logos and served at
  /brand/logos: full lockup, wordmark, mark — dark / white / on-white,
  transparent. Footer 'Logos' download link.

Co-Authored-By: Claude Opus 4.8 <noreply@anthropic.com>
</commit_message>
<xml_diff>
--- a/docs/presentation/biohackit-deck.pptx
+++ b/docs/presentation/biohackit-deck.pptx
@@ -2609,7 +2609,7 @@
                 <a:ea typeface="Jost" pitchFamily="34" charset="-122"/>
                 <a:cs typeface="Jost" pitchFamily="34" charset="-120"/>
               </a:rPr>
-              <a:t>TIMEPIE LONGEVITY FORUM · BIOHACKER TRACK · SHANGHAI 2026</a:t>
+              <a:t>THE 7TH TIMEPIE LONGEVITY FORUM · BIOHACKER TRACK</a:t>
             </a:r>
             <a:endParaRPr lang="en-US" sz="1250" dirty="0"/>
           </a:p>
@@ -2623,7 +2623,7 @@
         </p:nvSpPr>
         <p:spPr>
           <a:xfrm>
-            <a:off x="658368" y="1554480"/>
+            <a:off x="658368" y="1508760"/>
             <a:ext cx="10058400" cy="1554480"/>
           </a:xfrm>
           <a:prstGeom prst="rect">
@@ -2689,8 +2689,8 @@
         </p:nvSpPr>
         <p:spPr>
           <a:xfrm>
-            <a:off x="2807208" y="3145536"/>
-            <a:ext cx="5486400" cy="365760"/>
+            <a:off x="658368" y="3566160"/>
+            <a:ext cx="10058400" cy="731520"/>
           </a:xfrm>
           <a:prstGeom prst="rect">
             <a:avLst/>
@@ -2706,15 +2706,57 @@
               <a:buNone/>
             </a:pPr>
             <a:r>
-              <a:rPr lang="en-US" sz="1500" b="1" spc="600" kern="0" dirty="0">
-                <a:solidFill>
-                  <a:srgbClr val="25292C"/>
+              <a:rPr lang="en-US" sz="3000" dirty="0">
+                <a:solidFill>
+                  <a:srgbClr val="59636A"/>
                 </a:solidFill>
                 <a:latin typeface="Jost" pitchFamily="34" charset="0"/>
                 <a:ea typeface="Jost" pitchFamily="34" charset="-122"/>
                 <a:cs typeface="Jost" pitchFamily="34" charset="-120"/>
               </a:rPr>
-              <a:t>HACKING BIOLOGY</a:t>
+              <a:t>An open laboratory for longevity.</a:t>
+            </a:r>
+            <a:endParaRPr lang="en-US" sz="3000" dirty="0"/>
+          </a:p>
+        </p:txBody>
+      </p:sp>
+      <p:sp>
+        <p:nvSpPr>
+          <p:cNvPr id="6" name="Text 4"/>
+          <p:cNvSpPr/>
+          <p:nvPr/>
+        </p:nvSpPr>
+        <p:spPr>
+          <a:xfrm>
+            <a:off x="658368" y="4389120"/>
+            <a:ext cx="8412480" cy="914400"/>
+          </a:xfrm>
+          <a:prstGeom prst="rect">
+            <a:avLst/>
+          </a:prstGeom>
+          <a:noFill/>
+          <a:ln/>
+        </p:spPr>
+        <p:txBody>
+          <a:bodyPr wrap="square" lIns="0" tIns="0" rIns="0" bIns="0" rtlCol="0" anchor="t"/>
+          <a:lstStyle/>
+          <a:p>
+            <a:pPr indent="0" marL="0">
+              <a:lnSpc>
+                <a:spcPct val="112000"/>
+              </a:lnSpc>
+              <a:buNone/>
+            </a:pPr>
+            <a:r>
+              <a:rPr lang="en-US" sz="1500" dirty="0">
+                <a:solidFill>
+                  <a:srgbClr val="59636A"/>
+                </a:solidFill>
+                <a:latin typeface="Arial" pitchFamily="34" charset="0"/>
+                <a:ea typeface="Arial" pitchFamily="34" charset="-122"/>
+                <a:cs typeface="Arial" pitchFamily="34" charset="-120"/>
+              </a:rPr>
+              <a:t>Turning thousands of individual self-experiments into structured, comparable, open data — with safety engineered in, not bolted on.</a:t>
             </a:r>
             <a:endParaRPr lang="en-US" sz="1500" dirty="0"/>
           </a:p>
@@ -2722,14 +2764,14 @@
       </p:sp>
       <p:sp>
         <p:nvSpPr>
-          <p:cNvPr id="6" name="Text 4"/>
-          <p:cNvSpPr/>
-          <p:nvPr/>
-        </p:nvSpPr>
-        <p:spPr>
-          <a:xfrm>
-            <a:off x="658368" y="3657600"/>
-            <a:ext cx="10058400" cy="731520"/>
+          <p:cNvPr id="7" name="Text 5"/>
+          <p:cNvSpPr/>
+          <p:nvPr/>
+        </p:nvSpPr>
+        <p:spPr>
+          <a:xfrm>
+            <a:off x="658368" y="5321808"/>
+            <a:ext cx="3657600" cy="228600"/>
           </a:xfrm>
           <a:prstGeom prst="rect">
             <a:avLst/>
@@ -2745,104 +2787,125 @@
               <a:buNone/>
             </a:pPr>
             <a:r>
-              <a:rPr lang="en-US" sz="3000" dirty="0">
-                <a:solidFill>
-                  <a:srgbClr val="59636A"/>
+              <a:rPr lang="en-US" sz="1000" b="1" spc="300" kern="0" dirty="0">
+                <a:solidFill>
+                  <a:srgbClr val="8B9398"/>
                 </a:solidFill>
                 <a:latin typeface="Jost" pitchFamily="34" charset="0"/>
                 <a:ea typeface="Jost" pitchFamily="34" charset="-122"/>
                 <a:cs typeface="Jost" pitchFamily="34" charset="-120"/>
               </a:rPr>
-              <a:t>An open laboratory for longevity.</a:t>
-            </a:r>
-            <a:endParaRPr lang="en-US" sz="3000" dirty="0"/>
-          </a:p>
-        </p:txBody>
-      </p:sp>
-      <p:sp>
-        <p:nvSpPr>
-          <p:cNvPr id="7" name="Text 5"/>
-          <p:cNvSpPr/>
-          <p:nvPr/>
-        </p:nvSpPr>
-        <p:spPr>
-          <a:xfrm>
-            <a:off x="658368" y="4526280"/>
-            <a:ext cx="8412480" cy="914400"/>
-          </a:xfrm>
-          <a:prstGeom prst="rect">
-            <a:avLst/>
-          </a:prstGeom>
-          <a:noFill/>
-          <a:ln/>
-        </p:spPr>
-        <p:txBody>
-          <a:bodyPr wrap="square" lIns="0" tIns="0" rIns="0" bIns="0" rtlCol="0" anchor="t"/>
-          <a:lstStyle/>
-          <a:p>
-            <a:pPr indent="0" marL="0">
-              <a:lnSpc>
-                <a:spcPct val="112000"/>
-              </a:lnSpc>
-              <a:buNone/>
-            </a:pPr>
-            <a:r>
-              <a:rPr lang="en-US" sz="1500" dirty="0">
+              <a:t>PRESENTED AT</a:t>
+            </a:r>
+            <a:endParaRPr lang="en-US" sz="1000" dirty="0"/>
+          </a:p>
+        </p:txBody>
+      </p:sp>
+      <p:pic>
+        <p:nvPicPr>
+          <p:cNvPr id="8" name="Image 0" descr="443725_b862e52.png">    </p:cNvPr>
+          <p:cNvPicPr>
+            <a:picLocks noChangeAspect="1"/>
+          </p:cNvPicPr>
+          <p:nvPr/>
+        </p:nvPicPr>
+        <p:blipFill>
+          <a:blip r:embed="rId1"/>
+          <a:stretch>
+            <a:fillRect/>
+          </a:stretch>
+        </p:blipFill>
+        <p:spPr>
+          <a:xfrm>
+            <a:off x="658368" y="5559552"/>
+            <a:ext cx="1417320" cy="438156"/>
+          </a:xfrm>
+          <a:prstGeom prst="rect">
+            <a:avLst/>
+          </a:prstGeom>
+        </p:spPr>
+      </p:pic>
+      <p:sp>
+        <p:nvSpPr>
+          <p:cNvPr id="9" name="Text 6"/>
+          <p:cNvSpPr/>
+          <p:nvPr/>
+        </p:nvSpPr>
+        <p:spPr>
+          <a:xfrm>
+            <a:off x="2304288" y="5632704"/>
+            <a:ext cx="5486400" cy="274320"/>
+          </a:xfrm>
+          <a:prstGeom prst="rect">
+            <a:avLst/>
+          </a:prstGeom>
+          <a:noFill/>
+          <a:ln/>
+        </p:spPr>
+        <p:txBody>
+          <a:bodyPr wrap="square" lIns="0" tIns="0" rIns="0" bIns="0" rtlCol="0" anchor="ctr"/>
+          <a:lstStyle/>
+          <a:p>
+            <a:pPr indent="0" marL="0">
+              <a:buNone/>
+            </a:pPr>
+            <a:r>
+              <a:rPr lang="en-US" sz="1350" dirty="0">
                 <a:solidFill>
                   <a:srgbClr val="59636A"/>
-                </a:solidFill>
-                <a:latin typeface="Arial" pitchFamily="34" charset="0"/>
-                <a:ea typeface="Arial" pitchFamily="34" charset="-122"/>
-                <a:cs typeface="Arial" pitchFamily="34" charset="-120"/>
-              </a:rPr>
-              <a:t>Turning thousands of individual self-experiments into structured, comparable, open data — with safety engineered in, not bolted on.</a:t>
-            </a:r>
-            <a:endParaRPr lang="en-US" sz="1500" dirty="0"/>
-          </a:p>
-        </p:txBody>
-      </p:sp>
-      <p:sp>
-        <p:nvSpPr>
-          <p:cNvPr id="8" name="Text 6"/>
-          <p:cNvSpPr/>
-          <p:nvPr/>
-        </p:nvSpPr>
-        <p:spPr>
-          <a:xfrm>
-            <a:off x="658368" y="6126480"/>
-            <a:ext cx="10058400" cy="274320"/>
-          </a:xfrm>
-          <a:prstGeom prst="rect">
-            <a:avLst/>
-          </a:prstGeom>
-          <a:noFill/>
-          <a:ln/>
-        </p:spPr>
-        <p:txBody>
-          <a:bodyPr wrap="square" lIns="0" tIns="0" rIns="0" bIns="0" rtlCol="0" anchor="ctr"/>
-          <a:lstStyle/>
-          <a:p>
-            <a:pPr indent="0" marL="0">
-              <a:buNone/>
-            </a:pPr>
-            <a:r>
-              <a:rPr lang="en-US" sz="1200" b="1" spc="200" kern="0" dirty="0">
-                <a:solidFill>
-                  <a:srgbClr val="8B9398"/>
                 </a:solidFill>
                 <a:latin typeface="Jost" pitchFamily="34" charset="0"/>
                 <a:ea typeface="Jost" pitchFamily="34" charset="-122"/>
                 <a:cs typeface="Jost" pitchFamily="34" charset="-120"/>
               </a:rPr>
+              <a:t>September 12–13, 2026  ·  Shanghai</a:t>
+            </a:r>
+            <a:endParaRPr lang="en-US" sz="1350" dirty="0"/>
+          </a:p>
+        </p:txBody>
+      </p:sp>
+      <p:sp>
+        <p:nvSpPr>
+          <p:cNvPr id="10" name="Text 7"/>
+          <p:cNvSpPr/>
+          <p:nvPr/>
+        </p:nvSpPr>
+        <p:spPr>
+          <a:xfrm>
+            <a:off x="658368" y="6382512"/>
+            <a:ext cx="10058400" cy="274320"/>
+          </a:xfrm>
+          <a:prstGeom prst="rect">
+            <a:avLst/>
+          </a:prstGeom>
+          <a:noFill/>
+          <a:ln/>
+        </p:spPr>
+        <p:txBody>
+          <a:bodyPr wrap="square" lIns="0" tIns="0" rIns="0" bIns="0" rtlCol="0" anchor="ctr"/>
+          <a:lstStyle/>
+          <a:p>
+            <a:pPr indent="0" marL="0">
+              <a:buNone/>
+            </a:pPr>
+            <a:r>
+              <a:rPr lang="en-US" sz="1100" b="1" spc="200" kern="0" dirty="0">
+                <a:solidFill>
+                  <a:srgbClr val="8B9398"/>
+                </a:solidFill>
+                <a:latin typeface="Jost" pitchFamily="34" charset="0"/>
+                <a:ea typeface="Jost" pitchFamily="34" charset="-122"/>
+                <a:cs typeface="Jost" pitchFamily="34" charset="-120"/>
+              </a:rPr>
               <a:t>Open source · AGPL-3.0 · Non-profit — Hacking Biology</a:t>
             </a:r>
-            <a:endParaRPr lang="en-US" sz="1200" dirty="0"/>
-          </a:p>
-        </p:txBody>
-      </p:sp>
-      <p:sp>
-        <p:nvSpPr>
-          <p:cNvPr id="9" name="Shape 7"/>
+            <a:endParaRPr lang="en-US" sz="1100" dirty="0"/>
+          </a:p>
+        </p:txBody>
+      </p:sp>
+      <p:sp>
+        <p:nvSpPr>
+          <p:cNvPr id="11" name="Shape 8"/>
           <p:cNvSpPr/>
           <p:nvPr/>
         </p:nvSpPr>
@@ -2867,7 +2930,7 @@
       </p:sp>
       <p:sp>
         <p:nvSpPr>
-          <p:cNvPr id="10" name="Shape 8"/>
+          <p:cNvPr id="12" name="Shape 9"/>
           <p:cNvSpPr/>
           <p:nvPr/>
         </p:nvSpPr>

</xml_diff>

<commit_message>
Deck: add Join us and Contacts slides (18 total)
- 'Build this with us': the five open roles, matching the site.
- 'Contacts & references': Telegram Group Chat QR and WeChat QR side by
  side, plus email research@hackingbiology.com, biohack.it, the GitHub
  repository and Rapamycin News — all on one reference slide.

Co-Authored-By: Claude Opus 4.8 <noreply@anthropic.com>
</commit_message>
<xml_diff>
--- a/docs/presentation/biohackit-deck.pptx
+++ b/docs/presentation/biohackit-deck.pptx
@@ -21,9 +21,11 @@
     <p:sldId id="269" r:id="rId15"/>
     <p:sldId id="270" r:id="rId16"/>
     <p:sldId id="271" r:id="rId17"/>
+    <p:sldId id="272" r:id="rId18"/>
+    <p:sldId id="273" r:id="rId19"/>
   </p:sldIdLst>
   <p:notesMasterIdLst>
-    <p:notesMasterId r:id="rId18"/>
+    <p:notesMasterId r:id="rId20"/>
   </p:notesMasterIdLst>
   <p:sldSz cx="12191695" cy="6858000"/>
   <p:notesSz cx="6858000" cy="12191695"/>
@@ -1612,6 +1614,182 @@
             <a:fld id="{F7021451-1387-4CA6-816F-3879F97B5CBC}" type="slidenum">
               <a:rPr lang="en-US"/>
               <a:t>16</a:t>
+            </a:fld>
+            <a:endParaRPr lang="en-US"/>
+          </a:p>
+        </p:txBody>
+      </p:sp>
+    </p:spTree>
+    <p:extLst>
+      <p:ext uri="{BB962C8B-B14F-4D97-AF65-F5344CB8AC3E}">
+        <p14:creationId xmlns:p14="http://schemas.microsoft.com/office/powerpoint/2010/main" val="1024086991"/>
+      </p:ext>
+    </p:extLst>
+  </p:cSld>
+  <p:clrMapOvr>
+    <a:masterClrMapping/>
+  </p:clrMapOvr>
+</p:notes>
+</file>
+
+<file path=ppt/notesSlides/notesSlide17.xml><?xml version="1.0" encoding="utf-8"?>
+<p:notes xmlns:a="http://schemas.openxmlformats.org/drawingml/2006/main" xmlns:r="http://schemas.openxmlformats.org/officeDocument/2006/relationships" xmlns:p="http://schemas.openxmlformats.org/presentationml/2006/main">
+  <p:cSld>
+    <p:spTree>
+      <p:nvGrpSpPr>
+        <p:cNvPr id="1" name=""/>
+        <p:cNvGrpSpPr/>
+        <p:nvPr/>
+      </p:nvGrpSpPr>
+      <p:grpSpPr>
+        <a:xfrm>
+          <a:off x="0" y="0"/>
+          <a:ext cx="0" cy="0"/>
+          <a:chOff x="0" y="0"/>
+          <a:chExt cx="0" cy="0"/>
+        </a:xfrm>
+      </p:grpSpPr>
+      <p:sp>
+        <p:nvSpPr>
+          <p:cNvPr id="2" name="Slide Image Placeholder 1"/>
+          <p:cNvSpPr>
+            <a:spLocks noGrp="1" noRot="1" noChangeAspect="1"/>
+          </p:cNvSpPr>
+          <p:nvPr>
+            <p:ph type="sldImg"/>
+          </p:nvPr>
+        </p:nvSpPr>
+        <p:spPr/>
+      </p:sp>
+      <p:sp>
+        <p:nvSpPr>
+          <p:cNvPr id="3" name="Notes Placeholder 2"/>
+          <p:cNvSpPr>
+            <a:spLocks noGrp="1"/>
+          </p:cNvSpPr>
+          <p:nvPr>
+            <p:ph type="body" idx="1"/>
+          </p:nvPr>
+        </p:nvSpPr>
+        <p:spPr/>
+        <p:txBody>
+          <a:bodyPr/>
+          <a:lstStyle/>
+          <a:p>
+            <a:r>
+              <a:rPr lang="en-US" dirty="0"/>
+              <a:t/>
+            </a:r>
+            <a:endParaRPr lang="en-US" dirty="0"/>
+          </a:p>
+        </p:txBody>
+      </p:sp>
+      <p:sp>
+        <p:nvSpPr>
+          <p:cNvPr id="4" name="Slide Number Placeholder 3"/>
+          <p:cNvSpPr>
+            <a:spLocks noGrp="1"/>
+          </p:cNvSpPr>
+          <p:nvPr>
+            <p:ph type="sldNum" sz="quarter" idx="10"/>
+          </p:nvPr>
+        </p:nvSpPr>
+        <p:spPr/>
+        <p:txBody>
+          <a:bodyPr/>
+          <a:lstStyle/>
+          <a:p>
+            <a:fld id="{F7021451-1387-4CA6-816F-3879F97B5CBC}" type="slidenum">
+              <a:rPr lang="en-US"/>
+              <a:t>17</a:t>
+            </a:fld>
+            <a:endParaRPr lang="en-US"/>
+          </a:p>
+        </p:txBody>
+      </p:sp>
+    </p:spTree>
+    <p:extLst>
+      <p:ext uri="{BB962C8B-B14F-4D97-AF65-F5344CB8AC3E}">
+        <p14:creationId xmlns:p14="http://schemas.microsoft.com/office/powerpoint/2010/main" val="1024086991"/>
+      </p:ext>
+    </p:extLst>
+  </p:cSld>
+  <p:clrMapOvr>
+    <a:masterClrMapping/>
+  </p:clrMapOvr>
+</p:notes>
+</file>
+
+<file path=ppt/notesSlides/notesSlide18.xml><?xml version="1.0" encoding="utf-8"?>
+<p:notes xmlns:a="http://schemas.openxmlformats.org/drawingml/2006/main" xmlns:r="http://schemas.openxmlformats.org/officeDocument/2006/relationships" xmlns:p="http://schemas.openxmlformats.org/presentationml/2006/main">
+  <p:cSld>
+    <p:spTree>
+      <p:nvGrpSpPr>
+        <p:cNvPr id="1" name=""/>
+        <p:cNvGrpSpPr/>
+        <p:nvPr/>
+      </p:nvGrpSpPr>
+      <p:grpSpPr>
+        <a:xfrm>
+          <a:off x="0" y="0"/>
+          <a:ext cx="0" cy="0"/>
+          <a:chOff x="0" y="0"/>
+          <a:chExt cx="0" cy="0"/>
+        </a:xfrm>
+      </p:grpSpPr>
+      <p:sp>
+        <p:nvSpPr>
+          <p:cNvPr id="2" name="Slide Image Placeholder 1"/>
+          <p:cNvSpPr>
+            <a:spLocks noGrp="1" noRot="1" noChangeAspect="1"/>
+          </p:cNvSpPr>
+          <p:nvPr>
+            <p:ph type="sldImg"/>
+          </p:nvPr>
+        </p:nvSpPr>
+        <p:spPr/>
+      </p:sp>
+      <p:sp>
+        <p:nvSpPr>
+          <p:cNvPr id="3" name="Notes Placeholder 2"/>
+          <p:cNvSpPr>
+            <a:spLocks noGrp="1"/>
+          </p:cNvSpPr>
+          <p:nvPr>
+            <p:ph type="body" idx="1"/>
+          </p:nvPr>
+        </p:nvSpPr>
+        <p:spPr/>
+        <p:txBody>
+          <a:bodyPr/>
+          <a:lstStyle/>
+          <a:p>
+            <a:r>
+              <a:rPr lang="en-US" dirty="0"/>
+              <a:t/>
+            </a:r>
+            <a:endParaRPr lang="en-US" dirty="0"/>
+          </a:p>
+        </p:txBody>
+      </p:sp>
+      <p:sp>
+        <p:nvSpPr>
+          <p:cNvPr id="4" name="Slide Number Placeholder 3"/>
+          <p:cNvSpPr>
+            <a:spLocks noGrp="1"/>
+          </p:cNvSpPr>
+          <p:nvPr>
+            <p:ph type="sldNum" sz="quarter" idx="10"/>
+          </p:nvPr>
+        </p:nvSpPr>
+        <p:spPr/>
+        <p:txBody>
+          <a:bodyPr/>
+          <a:lstStyle/>
+          <a:p>
+            <a:fld id="{F7021451-1387-4CA6-816F-3879F97B5CBC}" type="slidenum">
+              <a:rPr lang="en-US"/>
+              <a:t>18</a:t>
             </a:fld>
             <a:endParaRPr lang="en-US"/>
           </a:p>
@@ -6895,6 +7073,1526 @@
         </p:nvSpPr>
         <p:spPr>
           <a:xfrm>
+            <a:off x="658368" y="566928"/>
+            <a:ext cx="10874959" cy="274320"/>
+          </a:xfrm>
+          <a:prstGeom prst="rect">
+            <a:avLst/>
+          </a:prstGeom>
+          <a:noFill/>
+          <a:ln/>
+        </p:spPr>
+        <p:txBody>
+          <a:bodyPr wrap="square" lIns="0" tIns="0" rIns="0" bIns="0" rtlCol="0" anchor="ctr"/>
+          <a:lstStyle/>
+          <a:p>
+            <a:pPr indent="0" marL="0">
+              <a:buNone/>
+            </a:pPr>
+            <a:r>
+              <a:rPr lang="en-US" sz="1250" b="1" spc="320" kern="0" dirty="0">
+                <a:solidFill>
+                  <a:srgbClr val="0C877A"/>
+                </a:solidFill>
+                <a:latin typeface="Jost" pitchFamily="34" charset="0"/>
+                <a:ea typeface="Jost" pitchFamily="34" charset="-122"/>
+                <a:cs typeface="Jost" pitchFamily="34" charset="-120"/>
+              </a:rPr>
+              <a:t>JOIN US</a:t>
+            </a:r>
+            <a:endParaRPr lang="en-US" sz="1250" dirty="0"/>
+          </a:p>
+        </p:txBody>
+      </p:sp>
+      <p:sp>
+        <p:nvSpPr>
+          <p:cNvPr id="3" name="Text 1"/>
+          <p:cNvSpPr/>
+          <p:nvPr/>
+        </p:nvSpPr>
+        <p:spPr>
+          <a:xfrm>
+            <a:off x="658368" y="932688"/>
+            <a:ext cx="10874959" cy="1371600"/>
+          </a:xfrm>
+          <a:prstGeom prst="rect">
+            <a:avLst/>
+          </a:prstGeom>
+          <a:noFill/>
+          <a:ln/>
+        </p:spPr>
+        <p:txBody>
+          <a:bodyPr wrap="square" lIns="0" tIns="0" rIns="0" bIns="0" rtlCol="0" anchor="t"/>
+          <a:lstStyle/>
+          <a:p>
+            <a:pPr indent="0" marL="0">
+              <a:lnSpc>
+                <a:spcPct val="102000"/>
+              </a:lnSpc>
+              <a:buNone/>
+            </a:pPr>
+            <a:r>
+              <a:rPr lang="en-US" sz="3300" dirty="0">
+                <a:solidFill>
+                  <a:srgbClr val="25292C"/>
+                </a:solidFill>
+                <a:latin typeface="Jost" pitchFamily="34" charset="0"/>
+                <a:ea typeface="Jost" pitchFamily="34" charset="-122"/>
+                <a:cs typeface="Jost" pitchFamily="34" charset="-120"/>
+              </a:rPr>
+              <a:t>Build this with us.</a:t>
+            </a:r>
+            <a:endParaRPr lang="en-US" sz="3300" dirty="0"/>
+          </a:p>
+        </p:txBody>
+      </p:sp>
+      <p:sp>
+        <p:nvSpPr>
+          <p:cNvPr id="4" name="Text 2"/>
+          <p:cNvSpPr/>
+          <p:nvPr/>
+        </p:nvSpPr>
+        <p:spPr>
+          <a:xfrm>
+            <a:off x="658368" y="1874520"/>
+            <a:ext cx="10424160" cy="914400"/>
+          </a:xfrm>
+          <a:prstGeom prst="rect">
+            <a:avLst/>
+          </a:prstGeom>
+          <a:noFill/>
+          <a:ln/>
+        </p:spPr>
+        <p:txBody>
+          <a:bodyPr wrap="square" lIns="0" tIns="0" rIns="0" bIns="0" rtlCol="0" anchor="t"/>
+          <a:lstStyle/>
+          <a:p>
+            <a:pPr indent="0" marL="0">
+              <a:lnSpc>
+                <a:spcPct val="112000"/>
+              </a:lnSpc>
+              <a:buNone/>
+            </a:pPr>
+            <a:r>
+              <a:rPr lang="en-US" sz="1500" dirty="0">
+                <a:solidFill>
+                  <a:srgbClr val="59636A"/>
+                </a:solidFill>
+                <a:latin typeface="Arial" pitchFamily="34" charset="0"/>
+                <a:ea typeface="Arial" pitchFamily="34" charset="-122"/>
+                <a:cs typeface="Arial" pitchFamily="34" charset="-120"/>
+              </a:rPr>
+              <a:t>This is open infrastructure, and it is early. Every one of these roles is genuinely open — and each one changes what the project becomes.</a:t>
+            </a:r>
+            <a:endParaRPr lang="en-US" sz="1500" dirty="0"/>
+          </a:p>
+        </p:txBody>
+      </p:sp>
+      <p:sp>
+        <p:nvSpPr>
+          <p:cNvPr id="5" name="Shape 3"/>
+          <p:cNvSpPr/>
+          <p:nvPr/>
+        </p:nvSpPr>
+        <p:spPr>
+          <a:xfrm>
+            <a:off x="658368" y="2697480"/>
+            <a:ext cx="2014057" cy="2651760"/>
+          </a:xfrm>
+          <a:prstGeom prst="roundRect">
+            <a:avLst>
+              <a:gd name="adj" fmla="val 4540"/>
+            </a:avLst>
+          </a:prstGeom>
+          <a:solidFill>
+            <a:srgbClr val="F1F4F3"/>
+          </a:solidFill>
+          <a:ln w="12700">
+            <a:solidFill>
+              <a:srgbClr val="DDE3E1"/>
+            </a:solidFill>
+            <a:prstDash val="solid"/>
+          </a:ln>
+        </p:spPr>
+      </p:sp>
+      <p:sp>
+        <p:nvSpPr>
+          <p:cNvPr id="6" name="Text 4"/>
+          <p:cNvSpPr/>
+          <p:nvPr/>
+        </p:nvSpPr>
+        <p:spPr>
+          <a:xfrm>
+            <a:off x="859536" y="2907792"/>
+            <a:ext cx="1611721" cy="685800"/>
+          </a:xfrm>
+          <a:prstGeom prst="rect">
+            <a:avLst/>
+          </a:prstGeom>
+          <a:noFill/>
+          <a:ln/>
+        </p:spPr>
+        <p:txBody>
+          <a:bodyPr wrap="square" lIns="0" tIns="0" rIns="0" bIns="0" rtlCol="0" anchor="ctr"/>
+          <a:lstStyle/>
+          <a:p>
+            <a:pPr indent="0" marL="0">
+              <a:lnSpc>
+                <a:spcPct val="100000"/>
+              </a:lnSpc>
+              <a:buNone/>
+            </a:pPr>
+            <a:r>
+              <a:rPr lang="en-US" sz="1450" b="1" dirty="0">
+                <a:solidFill>
+                  <a:srgbClr val="25292C"/>
+                </a:solidFill>
+                <a:latin typeface="Jost" pitchFamily="34" charset="0"/>
+                <a:ea typeface="Jost" pitchFamily="34" charset="-122"/>
+                <a:cs typeface="Jost" pitchFamily="34" charset="-120"/>
+              </a:rPr>
+              <a:t>Biohackers</a:t>
+            </a:r>
+            <a:endParaRPr lang="en-US" sz="1450" dirty="0"/>
+          </a:p>
+        </p:txBody>
+      </p:sp>
+      <p:sp>
+        <p:nvSpPr>
+          <p:cNvPr id="7" name="Text 5"/>
+          <p:cNvSpPr/>
+          <p:nvPr/>
+        </p:nvSpPr>
+        <p:spPr>
+          <a:xfrm>
+            <a:off x="859536" y="3657600"/>
+            <a:ext cx="1611721" cy="1554480"/>
+          </a:xfrm>
+          <a:prstGeom prst="rect">
+            <a:avLst/>
+          </a:prstGeom>
+          <a:noFill/>
+          <a:ln/>
+        </p:spPr>
+        <p:txBody>
+          <a:bodyPr wrap="square" lIns="0" tIns="0" rIns="0" bIns="0" rtlCol="0" anchor="t"/>
+          <a:lstStyle/>
+          <a:p>
+            <a:pPr indent="0" marL="0">
+              <a:lnSpc>
+                <a:spcPct val="112000"/>
+              </a:lnSpc>
+              <a:buNone/>
+            </a:pPr>
+            <a:r>
+              <a:rPr lang="en-US" sz="1150" dirty="0">
+                <a:solidFill>
+                  <a:srgbClr val="59636A"/>
+                </a:solidFill>
+                <a:latin typeface="Arial" pitchFamily="34" charset="0"/>
+                <a:ea typeface="Arial" pitchFamily="34" charset="-122"/>
+                <a:cs typeface="Arial" pitchFamily="34" charset="-120"/>
+              </a:rPr>
+              <a:t>Bring your experience into the specification, and your protocols and measurements into the software.</a:t>
+            </a:r>
+            <a:endParaRPr lang="en-US" sz="1150" dirty="0"/>
+          </a:p>
+        </p:txBody>
+      </p:sp>
+      <p:sp>
+        <p:nvSpPr>
+          <p:cNvPr id="8" name="Shape 6"/>
+          <p:cNvSpPr/>
+          <p:nvPr/>
+        </p:nvSpPr>
+        <p:spPr>
+          <a:xfrm>
+            <a:off x="2873593" y="2697480"/>
+            <a:ext cx="2014057" cy="2651760"/>
+          </a:xfrm>
+          <a:prstGeom prst="roundRect">
+            <a:avLst>
+              <a:gd name="adj" fmla="val 4540"/>
+            </a:avLst>
+          </a:prstGeom>
+          <a:solidFill>
+            <a:srgbClr val="F1F4F3"/>
+          </a:solidFill>
+          <a:ln w="12700">
+            <a:solidFill>
+              <a:srgbClr val="DDE3E1"/>
+            </a:solidFill>
+            <a:prstDash val="solid"/>
+          </a:ln>
+        </p:spPr>
+      </p:sp>
+      <p:sp>
+        <p:nvSpPr>
+          <p:cNvPr id="9" name="Text 7"/>
+          <p:cNvSpPr/>
+          <p:nvPr/>
+        </p:nvSpPr>
+        <p:spPr>
+          <a:xfrm>
+            <a:off x="3074761" y="2907792"/>
+            <a:ext cx="1611721" cy="685800"/>
+          </a:xfrm>
+          <a:prstGeom prst="rect">
+            <a:avLst/>
+          </a:prstGeom>
+          <a:noFill/>
+          <a:ln/>
+        </p:spPr>
+        <p:txBody>
+          <a:bodyPr wrap="square" lIns="0" tIns="0" rIns="0" bIns="0" rtlCol="0" anchor="ctr"/>
+          <a:lstStyle/>
+          <a:p>
+            <a:pPr indent="0" marL="0">
+              <a:lnSpc>
+                <a:spcPct val="100000"/>
+              </a:lnSpc>
+              <a:buNone/>
+            </a:pPr>
+            <a:r>
+              <a:rPr lang="en-US" sz="1450" b="1" dirty="0">
+                <a:solidFill>
+                  <a:srgbClr val="25292C"/>
+                </a:solidFill>
+                <a:latin typeface="Jost" pitchFamily="34" charset="0"/>
+                <a:ea typeface="Jost" pitchFamily="34" charset="-122"/>
+                <a:cs typeface="Jost" pitchFamily="34" charset="-120"/>
+              </a:rPr>
+              <a:t>Software hackers</a:t>
+            </a:r>
+            <a:endParaRPr lang="en-US" sz="1450" dirty="0"/>
+          </a:p>
+        </p:txBody>
+      </p:sp>
+      <p:sp>
+        <p:nvSpPr>
+          <p:cNvPr id="10" name="Text 8"/>
+          <p:cNvSpPr/>
+          <p:nvPr/>
+        </p:nvSpPr>
+        <p:spPr>
+          <a:xfrm>
+            <a:off x="3074761" y="3657600"/>
+            <a:ext cx="1611721" cy="1554480"/>
+          </a:xfrm>
+          <a:prstGeom prst="rect">
+            <a:avLst/>
+          </a:prstGeom>
+          <a:noFill/>
+          <a:ln/>
+        </p:spPr>
+        <p:txBody>
+          <a:bodyPr wrap="square" lIns="0" tIns="0" rIns="0" bIns="0" rtlCol="0" anchor="t"/>
+          <a:lstStyle/>
+          <a:p>
+            <a:pPr indent="0" marL="0">
+              <a:lnSpc>
+                <a:spcPct val="112000"/>
+              </a:lnSpc>
+              <a:buNone/>
+            </a:pPr>
+            <a:r>
+              <a:rPr lang="en-US" sz="1150" dirty="0">
+                <a:solidFill>
+                  <a:srgbClr val="59636A"/>
+                </a:solidFill>
+                <a:latin typeface="Arial" pitchFamily="34" charset="0"/>
+                <a:ea typeface="Arial" pitchFamily="34" charset="-122"/>
+                <a:cs typeface="Arial" pitchFamily="34" charset="-120"/>
+              </a:rPr>
+              <a:t>Build it. AGPL, public specification, open issues — written down before it is written in code.</a:t>
+            </a:r>
+            <a:endParaRPr lang="en-US" sz="1150" dirty="0"/>
+          </a:p>
+        </p:txBody>
+      </p:sp>
+      <p:sp>
+        <p:nvSpPr>
+          <p:cNvPr id="11" name="Shape 9"/>
+          <p:cNvSpPr/>
+          <p:nvPr/>
+        </p:nvSpPr>
+        <p:spPr>
+          <a:xfrm>
+            <a:off x="5088819" y="2697480"/>
+            <a:ext cx="2014057" cy="2651760"/>
+          </a:xfrm>
+          <a:prstGeom prst="roundRect">
+            <a:avLst>
+              <a:gd name="adj" fmla="val 4540"/>
+            </a:avLst>
+          </a:prstGeom>
+          <a:solidFill>
+            <a:srgbClr val="F1F4F3"/>
+          </a:solidFill>
+          <a:ln w="12700">
+            <a:solidFill>
+              <a:srgbClr val="DDE3E1"/>
+            </a:solidFill>
+            <a:prstDash val="solid"/>
+          </a:ln>
+        </p:spPr>
+      </p:sp>
+      <p:sp>
+        <p:nvSpPr>
+          <p:cNvPr id="12" name="Text 10"/>
+          <p:cNvSpPr/>
+          <p:nvPr/>
+        </p:nvSpPr>
+        <p:spPr>
+          <a:xfrm>
+            <a:off x="5289987" y="2907792"/>
+            <a:ext cx="1611721" cy="685800"/>
+          </a:xfrm>
+          <a:prstGeom prst="rect">
+            <a:avLst/>
+          </a:prstGeom>
+          <a:noFill/>
+          <a:ln/>
+        </p:spPr>
+        <p:txBody>
+          <a:bodyPr wrap="square" lIns="0" tIns="0" rIns="0" bIns="0" rtlCol="0" anchor="ctr"/>
+          <a:lstStyle/>
+          <a:p>
+            <a:pPr indent="0" marL="0">
+              <a:lnSpc>
+                <a:spcPct val="100000"/>
+              </a:lnSpc>
+              <a:buNone/>
+            </a:pPr>
+            <a:r>
+              <a:rPr lang="en-US" sz="1450" b="1" dirty="0">
+                <a:solidFill>
+                  <a:srgbClr val="25292C"/>
+                </a:solidFill>
+                <a:latin typeface="Jost" pitchFamily="34" charset="0"/>
+                <a:ea typeface="Jost" pitchFamily="34" charset="-122"/>
+                <a:cs typeface="Jost" pitchFamily="34" charset="-120"/>
+              </a:rPr>
+              <a:t>Researchers &amp; scientists</a:t>
+            </a:r>
+            <a:endParaRPr lang="en-US" sz="1450" dirty="0"/>
+          </a:p>
+        </p:txBody>
+      </p:sp>
+      <p:sp>
+        <p:nvSpPr>
+          <p:cNvPr id="13" name="Text 11"/>
+          <p:cNvSpPr/>
+          <p:nvPr/>
+        </p:nvSpPr>
+        <p:spPr>
+          <a:xfrm>
+            <a:off x="5289987" y="3657600"/>
+            <a:ext cx="1611721" cy="1554480"/>
+          </a:xfrm>
+          <a:prstGeom prst="rect">
+            <a:avLst/>
+          </a:prstGeom>
+          <a:noFill/>
+          <a:ln/>
+        </p:spPr>
+        <p:txBody>
+          <a:bodyPr wrap="square" lIns="0" tIns="0" rIns="0" bIns="0" rtlCol="0" anchor="t"/>
+          <a:lstStyle/>
+          <a:p>
+            <a:pPr indent="0" marL="0">
+              <a:lnSpc>
+                <a:spcPct val="112000"/>
+              </a:lnSpc>
+              <a:buNone/>
+            </a:pPr>
+            <a:r>
+              <a:rPr lang="en-US" sz="1150" dirty="0">
+                <a:solidFill>
+                  <a:srgbClr val="59636A"/>
+                </a:solidFill>
+                <a:latin typeface="Arial" pitchFamily="34" charset="0"/>
+                <a:ea typeface="Arial" pitchFamily="34" charset="-122"/>
+                <a:cs typeface="Arial" pitchFamily="34" charset="-120"/>
+              </a:rPr>
+              <a:t>Keep us honest on validity, uncertainty and evidence — while keeping it usable by a beginner.</a:t>
+            </a:r>
+            <a:endParaRPr lang="en-US" sz="1150" dirty="0"/>
+          </a:p>
+        </p:txBody>
+      </p:sp>
+      <p:sp>
+        <p:nvSpPr>
+          <p:cNvPr id="14" name="Shape 12"/>
+          <p:cNvSpPr/>
+          <p:nvPr/>
+        </p:nvSpPr>
+        <p:spPr>
+          <a:xfrm>
+            <a:off x="7304044" y="2697480"/>
+            <a:ext cx="2014057" cy="2651760"/>
+          </a:xfrm>
+          <a:prstGeom prst="roundRect">
+            <a:avLst>
+              <a:gd name="adj" fmla="val 4540"/>
+            </a:avLst>
+          </a:prstGeom>
+          <a:solidFill>
+            <a:srgbClr val="F1F4F3"/>
+          </a:solidFill>
+          <a:ln w="12700">
+            <a:solidFill>
+              <a:srgbClr val="DDE3E1"/>
+            </a:solidFill>
+            <a:prstDash val="solid"/>
+          </a:ln>
+        </p:spPr>
+      </p:sp>
+      <p:sp>
+        <p:nvSpPr>
+          <p:cNvPr id="15" name="Text 13"/>
+          <p:cNvSpPr/>
+          <p:nvPr/>
+        </p:nvSpPr>
+        <p:spPr>
+          <a:xfrm>
+            <a:off x="7505212" y="2907792"/>
+            <a:ext cx="1611721" cy="685800"/>
+          </a:xfrm>
+          <a:prstGeom prst="rect">
+            <a:avLst/>
+          </a:prstGeom>
+          <a:noFill/>
+          <a:ln/>
+        </p:spPr>
+        <p:txBody>
+          <a:bodyPr wrap="square" lIns="0" tIns="0" rIns="0" bIns="0" rtlCol="0" anchor="ctr"/>
+          <a:lstStyle/>
+          <a:p>
+            <a:pPr indent="0" marL="0">
+              <a:lnSpc>
+                <a:spcPct val="100000"/>
+              </a:lnSpc>
+              <a:buNone/>
+            </a:pPr>
+            <a:r>
+              <a:rPr lang="en-US" sz="1450" b="1" dirty="0">
+                <a:solidFill>
+                  <a:srgbClr val="25292C"/>
+                </a:solidFill>
+                <a:latin typeface="Jost" pitchFamily="34" charset="0"/>
+                <a:ea typeface="Jost" pitchFamily="34" charset="-122"/>
+                <a:cs typeface="Jost" pitchFamily="34" charset="-120"/>
+              </a:rPr>
+              <a:t>Longevity enthusiasts</a:t>
+            </a:r>
+            <a:endParaRPr lang="en-US" sz="1450" dirty="0"/>
+          </a:p>
+        </p:txBody>
+      </p:sp>
+      <p:sp>
+        <p:nvSpPr>
+          <p:cNvPr id="16" name="Text 14"/>
+          <p:cNvSpPr/>
+          <p:nvPr/>
+        </p:nvSpPr>
+        <p:spPr>
+          <a:xfrm>
+            <a:off x="7505212" y="3657600"/>
+            <a:ext cx="1611721" cy="1554480"/>
+          </a:xfrm>
+          <a:prstGeom prst="rect">
+            <a:avLst/>
+          </a:prstGeom>
+          <a:noFill/>
+          <a:ln/>
+        </p:spPr>
+        <p:txBody>
+          <a:bodyPr wrap="square" lIns="0" tIns="0" rIns="0" bIns="0" rtlCol="0" anchor="t"/>
+          <a:lstStyle/>
+          <a:p>
+            <a:pPr indent="0" marL="0">
+              <a:lnSpc>
+                <a:spcPct val="112000"/>
+              </a:lnSpc>
+              <a:buNone/>
+            </a:pPr>
+            <a:r>
+              <a:rPr lang="en-US" sz="1150" dirty="0">
+                <a:solidFill>
+                  <a:srgbClr val="59636A"/>
+                </a:solidFill>
+                <a:latin typeface="Arial" pitchFamily="34" charset="0"/>
+                <a:ea typeface="Arial" pitchFamily="34" charset="-122"/>
+                <a:cs typeface="Arial" pitchFamily="34" charset="-120"/>
+              </a:rPr>
+              <a:t>Volunteer to spread it: community, translation, events. A tool nobody knows about produces no data.</a:t>
+            </a:r>
+            <a:endParaRPr lang="en-US" sz="1150" dirty="0"/>
+          </a:p>
+        </p:txBody>
+      </p:sp>
+      <p:sp>
+        <p:nvSpPr>
+          <p:cNvPr id="17" name="Shape 15"/>
+          <p:cNvSpPr/>
+          <p:nvPr/>
+        </p:nvSpPr>
+        <p:spPr>
+          <a:xfrm>
+            <a:off x="9519270" y="2697480"/>
+            <a:ext cx="2014057" cy="2651760"/>
+          </a:xfrm>
+          <a:prstGeom prst="roundRect">
+            <a:avLst>
+              <a:gd name="adj" fmla="val 4540"/>
+            </a:avLst>
+          </a:prstGeom>
+          <a:solidFill>
+            <a:srgbClr val="F1F4F3"/>
+          </a:solidFill>
+          <a:ln w="12700">
+            <a:solidFill>
+              <a:srgbClr val="DDE3E1"/>
+            </a:solidFill>
+            <a:prstDash val="solid"/>
+          </a:ln>
+        </p:spPr>
+      </p:sp>
+      <p:sp>
+        <p:nvSpPr>
+          <p:cNvPr id="18" name="Text 16"/>
+          <p:cNvSpPr/>
+          <p:nvPr/>
+        </p:nvSpPr>
+        <p:spPr>
+          <a:xfrm>
+            <a:off x="9720438" y="2907792"/>
+            <a:ext cx="1611721" cy="685800"/>
+          </a:xfrm>
+          <a:prstGeom prst="rect">
+            <a:avLst/>
+          </a:prstGeom>
+          <a:noFill/>
+          <a:ln/>
+        </p:spPr>
+        <p:txBody>
+          <a:bodyPr wrap="square" lIns="0" tIns="0" rIns="0" bIns="0" rtlCol="0" anchor="ctr"/>
+          <a:lstStyle/>
+          <a:p>
+            <a:pPr indent="0" marL="0">
+              <a:lnSpc>
+                <a:spcPct val="100000"/>
+              </a:lnSpc>
+              <a:buNone/>
+            </a:pPr>
+            <a:r>
+              <a:rPr lang="en-US" sz="1450" b="1" dirty="0">
+                <a:solidFill>
+                  <a:srgbClr val="25292C"/>
+                </a:solidFill>
+                <a:latin typeface="Jost" pitchFamily="34" charset="0"/>
+                <a:ea typeface="Jost" pitchFamily="34" charset="-122"/>
+                <a:cs typeface="Jost" pitchFamily="34" charset="-120"/>
+              </a:rPr>
+              <a:t>Fundraisers &amp; philanthropy</a:t>
+            </a:r>
+            <a:endParaRPr lang="en-US" sz="1450" dirty="0"/>
+          </a:p>
+        </p:txBody>
+      </p:sp>
+      <p:sp>
+        <p:nvSpPr>
+          <p:cNvPr id="19" name="Text 17"/>
+          <p:cNvSpPr/>
+          <p:nvPr/>
+        </p:nvSpPr>
+        <p:spPr>
+          <a:xfrm>
+            <a:off x="9720438" y="3657600"/>
+            <a:ext cx="1611721" cy="1554480"/>
+          </a:xfrm>
+          <a:prstGeom prst="rect">
+            <a:avLst/>
+          </a:prstGeom>
+          <a:noFill/>
+          <a:ln/>
+        </p:spPr>
+        <p:txBody>
+          <a:bodyPr wrap="square" lIns="0" tIns="0" rIns="0" bIns="0" rtlCol="0" anchor="t"/>
+          <a:lstStyle/>
+          <a:p>
+            <a:pPr indent="0" marL="0">
+              <a:lnSpc>
+                <a:spcPct val="112000"/>
+              </a:lnSpc>
+              <a:buNone/>
+            </a:pPr>
+            <a:r>
+              <a:rPr lang="en-US" sz="1150" dirty="0">
+                <a:solidFill>
+                  <a:srgbClr val="59636A"/>
+                </a:solidFill>
+                <a:latin typeface="Arial" pitchFamily="34" charset="0"/>
+                <a:ea typeface="Arial" pitchFamily="34" charset="-122"/>
+                <a:cs typeface="Arial" pitchFamily="34" charset="-120"/>
+              </a:rPr>
+              <a:t>Build the funding pipeline — grants and philanthropy — so it never has to become commercial.</a:t>
+            </a:r>
+            <a:endParaRPr lang="en-US" sz="1150" dirty="0"/>
+          </a:p>
+        </p:txBody>
+      </p:sp>
+      <p:sp>
+        <p:nvSpPr>
+          <p:cNvPr id="20" name="Text 18"/>
+          <p:cNvSpPr/>
+          <p:nvPr/>
+        </p:nvSpPr>
+        <p:spPr>
+          <a:xfrm>
+            <a:off x="658368" y="5623560"/>
+            <a:ext cx="10424160" cy="914400"/>
+          </a:xfrm>
+          <a:prstGeom prst="rect">
+            <a:avLst/>
+          </a:prstGeom>
+          <a:noFill/>
+          <a:ln/>
+        </p:spPr>
+        <p:txBody>
+          <a:bodyPr wrap="square" lIns="0" tIns="0" rIns="0" bIns="0" rtlCol="0" anchor="t"/>
+          <a:lstStyle/>
+          <a:p>
+            <a:pPr indent="0" marL="0">
+              <a:lnSpc>
+                <a:spcPct val="112000"/>
+              </a:lnSpc>
+              <a:buNone/>
+            </a:pPr>
+            <a:r>
+              <a:rPr lang="en-US" sz="1400" dirty="0">
+                <a:solidFill>
+                  <a:srgbClr val="25292C"/>
+                </a:solidFill>
+                <a:latin typeface="Arial" pitchFamily="34" charset="0"/>
+                <a:ea typeface="Arial" pitchFamily="34" charset="-122"/>
+                <a:cs typeface="Arial" pitchFamily="34" charset="-120"/>
+              </a:rPr>
+              <a:t>Tell us which of the five you are — and what you would like to work on.</a:t>
+            </a:r>
+            <a:endParaRPr lang="en-US" sz="1400" dirty="0"/>
+          </a:p>
+        </p:txBody>
+      </p:sp>
+    </p:spTree>
+  </p:cSld>
+  <p:clrMapOvr>
+    <a:masterClrMapping/>
+  </p:clrMapOvr>
+</p:sld>
+</file>
+
+<file path=ppt/slides/slide17.xml><?xml version="1.0" encoding="utf-8"?>
+<p:sld xmlns:a="http://schemas.openxmlformats.org/drawingml/2006/main" xmlns:r="http://schemas.openxmlformats.org/officeDocument/2006/relationships" xmlns:p="http://schemas.openxmlformats.org/presentationml/2006/main">
+  <p:cSld name="Slide 17">
+    <p:bg>
+      <p:bgPr>
+        <a:solidFill>
+          <a:srgbClr val="FFFFFF"/>
+        </a:solidFill>
+      </p:bgPr>
+    </p:bg>
+    <p:spTree>
+      <p:nvGrpSpPr>
+        <p:cNvPr id="1" name=""/>
+        <p:cNvGrpSpPr/>
+        <p:nvPr/>
+      </p:nvGrpSpPr>
+      <p:grpSpPr>
+        <a:xfrm>
+          <a:off x="0" y="0"/>
+          <a:ext cx="0" cy="0"/>
+          <a:chOff x="0" y="0"/>
+          <a:chExt cx="0" cy="0"/>
+        </a:xfrm>
+      </p:grpSpPr>
+      <p:sp>
+        <p:nvSpPr>
+          <p:cNvPr id="2" name="Text 0"/>
+          <p:cNvSpPr/>
+          <p:nvPr/>
+        </p:nvSpPr>
+        <p:spPr>
+          <a:xfrm>
+            <a:off x="658368" y="566928"/>
+            <a:ext cx="10874959" cy="274320"/>
+          </a:xfrm>
+          <a:prstGeom prst="rect">
+            <a:avLst/>
+          </a:prstGeom>
+          <a:noFill/>
+          <a:ln/>
+        </p:spPr>
+        <p:txBody>
+          <a:bodyPr wrap="square" lIns="0" tIns="0" rIns="0" bIns="0" rtlCol="0" anchor="ctr"/>
+          <a:lstStyle/>
+          <a:p>
+            <a:pPr indent="0" marL="0">
+              <a:buNone/>
+            </a:pPr>
+            <a:r>
+              <a:rPr lang="en-US" sz="1250" b="1" spc="320" kern="0" dirty="0">
+                <a:solidFill>
+                  <a:srgbClr val="0C877A"/>
+                </a:solidFill>
+                <a:latin typeface="Jost" pitchFamily="34" charset="0"/>
+                <a:ea typeface="Jost" pitchFamily="34" charset="-122"/>
+                <a:cs typeface="Jost" pitchFamily="34" charset="-120"/>
+              </a:rPr>
+              <a:t>GET IN TOUCH</a:t>
+            </a:r>
+            <a:endParaRPr lang="en-US" sz="1250" dirty="0"/>
+          </a:p>
+        </p:txBody>
+      </p:sp>
+      <p:sp>
+        <p:nvSpPr>
+          <p:cNvPr id="3" name="Text 1"/>
+          <p:cNvSpPr/>
+          <p:nvPr/>
+        </p:nvSpPr>
+        <p:spPr>
+          <a:xfrm>
+            <a:off x="658368" y="932688"/>
+            <a:ext cx="10874959" cy="1371600"/>
+          </a:xfrm>
+          <a:prstGeom prst="rect">
+            <a:avLst/>
+          </a:prstGeom>
+          <a:noFill/>
+          <a:ln/>
+        </p:spPr>
+        <p:txBody>
+          <a:bodyPr wrap="square" lIns="0" tIns="0" rIns="0" bIns="0" rtlCol="0" anchor="t"/>
+          <a:lstStyle/>
+          <a:p>
+            <a:pPr indent="0" marL="0">
+              <a:lnSpc>
+                <a:spcPct val="102000"/>
+              </a:lnSpc>
+              <a:buNone/>
+            </a:pPr>
+            <a:r>
+              <a:rPr lang="en-US" sz="3300" dirty="0">
+                <a:solidFill>
+                  <a:srgbClr val="25292C"/>
+                </a:solidFill>
+                <a:latin typeface="Jost" pitchFamily="34" charset="0"/>
+                <a:ea typeface="Jost" pitchFamily="34" charset="-122"/>
+                <a:cs typeface="Jost" pitchFamily="34" charset="-120"/>
+              </a:rPr>
+              <a:t>Contacts &amp; references.</a:t>
+            </a:r>
+            <a:endParaRPr lang="en-US" sz="3300" dirty="0"/>
+          </a:p>
+        </p:txBody>
+      </p:sp>
+      <p:sp>
+        <p:nvSpPr>
+          <p:cNvPr id="4" name="Shape 2"/>
+          <p:cNvSpPr/>
+          <p:nvPr/>
+        </p:nvSpPr>
+        <p:spPr>
+          <a:xfrm>
+            <a:off x="658368" y="2286000"/>
+            <a:ext cx="2788920" cy="3703320"/>
+          </a:xfrm>
+          <a:prstGeom prst="roundRect">
+            <a:avLst>
+              <a:gd name="adj" fmla="val 3279"/>
+            </a:avLst>
+          </a:prstGeom>
+          <a:solidFill>
+            <a:srgbClr val="F1F4F3"/>
+          </a:solidFill>
+          <a:ln w="12700">
+            <a:solidFill>
+              <a:srgbClr val="DDE3E1"/>
+            </a:solidFill>
+            <a:prstDash val="solid"/>
+          </a:ln>
+        </p:spPr>
+      </p:sp>
+      <p:sp>
+        <p:nvSpPr>
+          <p:cNvPr id="5" name="Text 3"/>
+          <p:cNvSpPr/>
+          <p:nvPr/>
+        </p:nvSpPr>
+        <p:spPr>
+          <a:xfrm>
+            <a:off x="886968" y="2487168"/>
+            <a:ext cx="2331720" cy="274320"/>
+          </a:xfrm>
+          <a:prstGeom prst="rect">
+            <a:avLst/>
+          </a:prstGeom>
+          <a:noFill/>
+          <a:ln/>
+        </p:spPr>
+        <p:txBody>
+          <a:bodyPr wrap="square" lIns="0" tIns="0" rIns="0" bIns="0" rtlCol="0" anchor="ctr"/>
+          <a:lstStyle/>
+          <a:p>
+            <a:pPr indent="0" marL="0">
+              <a:buNone/>
+            </a:pPr>
+            <a:r>
+              <a:rPr lang="en-US" sz="1200" b="1" spc="150" kern="0" dirty="0">
+                <a:solidFill>
+                  <a:srgbClr val="0C877A"/>
+                </a:solidFill>
+                <a:latin typeface="Jost" pitchFamily="34" charset="0"/>
+                <a:ea typeface="Jost" pitchFamily="34" charset="-122"/>
+                <a:cs typeface="Jost" pitchFamily="34" charset="-120"/>
+              </a:rPr>
+              <a:t>Telegram Group Chat</a:t>
+            </a:r>
+            <a:endParaRPr lang="en-US" sz="1200" dirty="0"/>
+          </a:p>
+        </p:txBody>
+      </p:sp>
+      <p:pic>
+        <p:nvPicPr>
+          <p:cNvPr id="6" name="Image 0" descr="telegram-qr.png">    </p:cNvPr>
+          <p:cNvPicPr>
+            <a:picLocks noChangeAspect="1"/>
+          </p:cNvPicPr>
+          <p:nvPr/>
+        </p:nvPicPr>
+        <p:blipFill>
+          <a:blip r:embed="rId1"/>
+          <a:stretch>
+            <a:fillRect/>
+          </a:stretch>
+        </p:blipFill>
+        <p:spPr>
+          <a:xfrm>
+            <a:off x="1115568" y="2907792"/>
+            <a:ext cx="1874520" cy="1874520"/>
+          </a:xfrm>
+          <a:prstGeom prst="rect">
+            <a:avLst/>
+          </a:prstGeom>
+        </p:spPr>
+      </p:pic>
+      <p:sp>
+        <p:nvSpPr>
+          <p:cNvPr id="7" name="Text 4"/>
+          <p:cNvSpPr/>
+          <p:nvPr/>
+        </p:nvSpPr>
+        <p:spPr>
+          <a:xfrm>
+            <a:off x="886968" y="4956048"/>
+            <a:ext cx="2331720" cy="822960"/>
+          </a:xfrm>
+          <a:prstGeom prst="rect">
+            <a:avLst/>
+          </a:prstGeom>
+          <a:noFill/>
+          <a:ln/>
+        </p:spPr>
+        <p:txBody>
+          <a:bodyPr wrap="square" lIns="0" tIns="0" rIns="0" bIns="0" rtlCol="0" anchor="t"/>
+          <a:lstStyle/>
+          <a:p>
+            <a:pPr indent="0" marL="0">
+              <a:lnSpc>
+                <a:spcPct val="112000"/>
+              </a:lnSpc>
+              <a:buNone/>
+            </a:pPr>
+            <a:r>
+              <a:rPr lang="en-US" sz="1100" dirty="0">
+                <a:solidFill>
+                  <a:srgbClr val="59636A"/>
+                </a:solidFill>
+                <a:latin typeface="Arial" pitchFamily="34" charset="0"/>
+                <a:ea typeface="Arial" pitchFamily="34" charset="-122"/>
+                <a:cs typeface="Arial" pitchFamily="34" charset="-120"/>
+              </a:rPr>
+              <a:t>Scan or search the channel — project updates and open discussion.</a:t>
+            </a:r>
+            <a:endParaRPr lang="en-US" sz="1100" dirty="0"/>
+          </a:p>
+        </p:txBody>
+      </p:sp>
+      <p:sp>
+        <p:nvSpPr>
+          <p:cNvPr id="8" name="Shape 5"/>
+          <p:cNvSpPr/>
+          <p:nvPr/>
+        </p:nvSpPr>
+        <p:spPr>
+          <a:xfrm>
+            <a:off x="3767328" y="2286000"/>
+            <a:ext cx="2788920" cy="3703320"/>
+          </a:xfrm>
+          <a:prstGeom prst="roundRect">
+            <a:avLst>
+              <a:gd name="adj" fmla="val 3279"/>
+            </a:avLst>
+          </a:prstGeom>
+          <a:solidFill>
+            <a:srgbClr val="F1F4F3"/>
+          </a:solidFill>
+          <a:ln w="12700">
+            <a:solidFill>
+              <a:srgbClr val="DDE3E1"/>
+            </a:solidFill>
+            <a:prstDash val="solid"/>
+          </a:ln>
+        </p:spPr>
+      </p:sp>
+      <p:sp>
+        <p:nvSpPr>
+          <p:cNvPr id="9" name="Text 6"/>
+          <p:cNvSpPr/>
+          <p:nvPr/>
+        </p:nvSpPr>
+        <p:spPr>
+          <a:xfrm>
+            <a:off x="3995928" y="2487168"/>
+            <a:ext cx="2331720" cy="274320"/>
+          </a:xfrm>
+          <a:prstGeom prst="rect">
+            <a:avLst/>
+          </a:prstGeom>
+          <a:noFill/>
+          <a:ln/>
+        </p:spPr>
+        <p:txBody>
+          <a:bodyPr wrap="square" lIns="0" tIns="0" rIns="0" bIns="0" rtlCol="0" anchor="ctr"/>
+          <a:lstStyle/>
+          <a:p>
+            <a:pPr indent="0" marL="0">
+              <a:buNone/>
+            </a:pPr>
+            <a:r>
+              <a:rPr lang="en-US" sz="1200" b="1" spc="150" kern="0" dirty="0">
+                <a:solidFill>
+                  <a:srgbClr val="0C877A"/>
+                </a:solidFill>
+                <a:latin typeface="Jost" pitchFamily="34" charset="0"/>
+                <a:ea typeface="Jost" pitchFamily="34" charset="-122"/>
+                <a:cs typeface="Jost" pitchFamily="34" charset="-120"/>
+              </a:rPr>
+              <a:t>WeChat 微信</a:t>
+            </a:r>
+            <a:endParaRPr lang="en-US" sz="1200" dirty="0"/>
+          </a:p>
+        </p:txBody>
+      </p:sp>
+      <p:pic>
+        <p:nvPicPr>
+          <p:cNvPr id="10" name="Image 1" descr="wechat-qr.png">    </p:cNvPr>
+          <p:cNvPicPr>
+            <a:picLocks noChangeAspect="1"/>
+          </p:cNvPicPr>
+          <p:nvPr/>
+        </p:nvPicPr>
+        <p:blipFill>
+          <a:blip r:embed="rId2"/>
+          <a:stretch>
+            <a:fillRect/>
+          </a:stretch>
+        </p:blipFill>
+        <p:spPr>
+          <a:xfrm>
+            <a:off x="4224528" y="2907792"/>
+            <a:ext cx="1874520" cy="1874520"/>
+          </a:xfrm>
+          <a:prstGeom prst="rect">
+            <a:avLst/>
+          </a:prstGeom>
+        </p:spPr>
+      </p:pic>
+      <p:sp>
+        <p:nvSpPr>
+          <p:cNvPr id="11" name="Text 7"/>
+          <p:cNvSpPr/>
+          <p:nvPr/>
+        </p:nvSpPr>
+        <p:spPr>
+          <a:xfrm>
+            <a:off x="3995928" y="4956048"/>
+            <a:ext cx="2331720" cy="822960"/>
+          </a:xfrm>
+          <a:prstGeom prst="rect">
+            <a:avLst/>
+          </a:prstGeom>
+          <a:noFill/>
+          <a:ln/>
+        </p:spPr>
+        <p:txBody>
+          <a:bodyPr wrap="square" lIns="0" tIns="0" rIns="0" bIns="0" rtlCol="0" anchor="t"/>
+          <a:lstStyle/>
+          <a:p>
+            <a:pPr indent="0" marL="0">
+              <a:lnSpc>
+                <a:spcPct val="112000"/>
+              </a:lnSpc>
+              <a:buNone/>
+            </a:pPr>
+            <a:r>
+              <a:rPr lang="en-US" sz="1100" dirty="0">
+                <a:solidFill>
+                  <a:srgbClr val="59636A"/>
+                </a:solidFill>
+                <a:latin typeface="Arial" pitchFamily="34" charset="0"/>
+                <a:ea typeface="Arial" pitchFamily="34" charset="-122"/>
+                <a:cs typeface="Arial" pitchFamily="34" charset="-120"/>
+              </a:rPr>
+              <a:t>Scan to add Fabio — he will add you to the biohack.it group chat.</a:t>
+            </a:r>
+            <a:endParaRPr lang="en-US" sz="1100" dirty="0"/>
+          </a:p>
+        </p:txBody>
+      </p:sp>
+      <p:sp>
+        <p:nvSpPr>
+          <p:cNvPr id="12" name="Shape 8"/>
+          <p:cNvSpPr/>
+          <p:nvPr/>
+        </p:nvSpPr>
+        <p:spPr>
+          <a:xfrm>
+            <a:off x="6876288" y="2286000"/>
+            <a:ext cx="4657039" cy="3703320"/>
+          </a:xfrm>
+          <a:prstGeom prst="roundRect">
+            <a:avLst>
+              <a:gd name="adj" fmla="val 2469"/>
+            </a:avLst>
+          </a:prstGeom>
+          <a:solidFill>
+            <a:srgbClr val="FFFFFF"/>
+          </a:solidFill>
+          <a:ln w="12700">
+            <a:solidFill>
+              <a:srgbClr val="DDE3E1"/>
+            </a:solidFill>
+            <a:prstDash val="solid"/>
+          </a:ln>
+        </p:spPr>
+      </p:sp>
+      <p:sp>
+        <p:nvSpPr>
+          <p:cNvPr id="13" name="Text 9"/>
+          <p:cNvSpPr/>
+          <p:nvPr/>
+        </p:nvSpPr>
+        <p:spPr>
+          <a:xfrm>
+            <a:off x="7168896" y="2606040"/>
+            <a:ext cx="4071823" cy="228600"/>
+          </a:xfrm>
+          <a:prstGeom prst="rect">
+            <a:avLst/>
+          </a:prstGeom>
+          <a:noFill/>
+          <a:ln/>
+        </p:spPr>
+        <p:txBody>
+          <a:bodyPr wrap="square" lIns="0" tIns="0" rIns="0" bIns="0" rtlCol="0" anchor="ctr"/>
+          <a:lstStyle/>
+          <a:p>
+            <a:pPr indent="0" marL="0">
+              <a:buNone/>
+            </a:pPr>
+            <a:r>
+              <a:rPr lang="en-US" sz="1000" b="1" spc="250" kern="0" dirty="0">
+                <a:solidFill>
+                  <a:srgbClr val="8B9398"/>
+                </a:solidFill>
+                <a:latin typeface="Jost" pitchFamily="34" charset="0"/>
+                <a:ea typeface="Jost" pitchFamily="34" charset="-122"/>
+                <a:cs typeface="Jost" pitchFamily="34" charset="-120"/>
+              </a:rPr>
+              <a:t>EMAIL</a:t>
+            </a:r>
+            <a:endParaRPr lang="en-US" sz="1000" dirty="0"/>
+          </a:p>
+        </p:txBody>
+      </p:sp>
+      <p:sp>
+        <p:nvSpPr>
+          <p:cNvPr id="14" name="Text 10"/>
+          <p:cNvSpPr/>
+          <p:nvPr/>
+        </p:nvSpPr>
+        <p:spPr>
+          <a:xfrm>
+            <a:off x="7168896" y="2843784"/>
+            <a:ext cx="4071823" cy="384048"/>
+          </a:xfrm>
+          <a:prstGeom prst="rect">
+            <a:avLst/>
+          </a:prstGeom>
+          <a:noFill/>
+          <a:ln/>
+        </p:spPr>
+        <p:txBody>
+          <a:bodyPr wrap="square" lIns="0" tIns="0" rIns="0" bIns="0" rtlCol="0" anchor="ctr"/>
+          <a:lstStyle/>
+          <a:p>
+            <a:pPr indent="0" marL="0">
+              <a:buNone/>
+            </a:pPr>
+            <a:r>
+              <a:rPr lang="en-US" sz="1600" dirty="0">
+                <a:solidFill>
+                  <a:srgbClr val="25292C"/>
+                </a:solidFill>
+                <a:latin typeface="Jost" pitchFamily="34" charset="0"/>
+                <a:ea typeface="Jost" pitchFamily="34" charset="-122"/>
+                <a:cs typeface="Jost" pitchFamily="34" charset="-120"/>
+              </a:rPr>
+              <a:t>research@hackingbiology.com</a:t>
+            </a:r>
+            <a:endParaRPr lang="en-US" sz="1600" dirty="0"/>
+          </a:p>
+        </p:txBody>
+      </p:sp>
+      <p:sp>
+        <p:nvSpPr>
+          <p:cNvPr id="15" name="Text 11"/>
+          <p:cNvSpPr/>
+          <p:nvPr/>
+        </p:nvSpPr>
+        <p:spPr>
+          <a:xfrm>
+            <a:off x="7168896" y="3474720"/>
+            <a:ext cx="4071823" cy="228600"/>
+          </a:xfrm>
+          <a:prstGeom prst="rect">
+            <a:avLst/>
+          </a:prstGeom>
+          <a:noFill/>
+          <a:ln/>
+        </p:spPr>
+        <p:txBody>
+          <a:bodyPr wrap="square" lIns="0" tIns="0" rIns="0" bIns="0" rtlCol="0" anchor="ctr"/>
+          <a:lstStyle/>
+          <a:p>
+            <a:pPr indent="0" marL="0">
+              <a:buNone/>
+            </a:pPr>
+            <a:r>
+              <a:rPr lang="en-US" sz="1000" b="1" spc="250" kern="0" dirty="0">
+                <a:solidFill>
+                  <a:srgbClr val="8B9398"/>
+                </a:solidFill>
+                <a:latin typeface="Jost" pitchFamily="34" charset="0"/>
+                <a:ea typeface="Jost" pitchFamily="34" charset="-122"/>
+                <a:cs typeface="Jost" pitchFamily="34" charset="-120"/>
+              </a:rPr>
+              <a:t>WEBSITE</a:t>
+            </a:r>
+            <a:endParaRPr lang="en-US" sz="1000" dirty="0"/>
+          </a:p>
+        </p:txBody>
+      </p:sp>
+      <p:sp>
+        <p:nvSpPr>
+          <p:cNvPr id="16" name="Text 12"/>
+          <p:cNvSpPr/>
+          <p:nvPr/>
+        </p:nvSpPr>
+        <p:spPr>
+          <a:xfrm>
+            <a:off x="7168896" y="3712464"/>
+            <a:ext cx="4071823" cy="384048"/>
+          </a:xfrm>
+          <a:prstGeom prst="rect">
+            <a:avLst/>
+          </a:prstGeom>
+          <a:noFill/>
+          <a:ln/>
+        </p:spPr>
+        <p:txBody>
+          <a:bodyPr wrap="square" lIns="0" tIns="0" rIns="0" bIns="0" rtlCol="0" anchor="ctr"/>
+          <a:lstStyle/>
+          <a:p>
+            <a:pPr indent="0" marL="0">
+              <a:buNone/>
+            </a:pPr>
+            <a:r>
+              <a:rPr lang="en-US" sz="1600" dirty="0">
+                <a:solidFill>
+                  <a:srgbClr val="25292C"/>
+                </a:solidFill>
+                <a:latin typeface="Jost" pitchFamily="34" charset="0"/>
+                <a:ea typeface="Jost" pitchFamily="34" charset="-122"/>
+                <a:cs typeface="Jost" pitchFamily="34" charset="-120"/>
+              </a:rPr>
+              <a:t>biohack.it</a:t>
+            </a:r>
+            <a:endParaRPr lang="en-US" sz="1600" dirty="0"/>
+          </a:p>
+        </p:txBody>
+      </p:sp>
+      <p:sp>
+        <p:nvSpPr>
+          <p:cNvPr id="17" name="Text 13"/>
+          <p:cNvSpPr/>
+          <p:nvPr/>
+        </p:nvSpPr>
+        <p:spPr>
+          <a:xfrm>
+            <a:off x="7168896" y="4343400"/>
+            <a:ext cx="4071823" cy="228600"/>
+          </a:xfrm>
+          <a:prstGeom prst="rect">
+            <a:avLst/>
+          </a:prstGeom>
+          <a:noFill/>
+          <a:ln/>
+        </p:spPr>
+        <p:txBody>
+          <a:bodyPr wrap="square" lIns="0" tIns="0" rIns="0" bIns="0" rtlCol="0" anchor="ctr"/>
+          <a:lstStyle/>
+          <a:p>
+            <a:pPr indent="0" marL="0">
+              <a:buNone/>
+            </a:pPr>
+            <a:r>
+              <a:rPr lang="en-US" sz="1000" b="1" spc="250" kern="0" dirty="0">
+                <a:solidFill>
+                  <a:srgbClr val="8B9398"/>
+                </a:solidFill>
+                <a:latin typeface="Jost" pitchFamily="34" charset="0"/>
+                <a:ea typeface="Jost" pitchFamily="34" charset="-122"/>
+                <a:cs typeface="Jost" pitchFamily="34" charset="-120"/>
+              </a:rPr>
+              <a:t>SOURCE</a:t>
+            </a:r>
+            <a:endParaRPr lang="en-US" sz="1000" dirty="0"/>
+          </a:p>
+        </p:txBody>
+      </p:sp>
+      <p:sp>
+        <p:nvSpPr>
+          <p:cNvPr id="18" name="Text 14"/>
+          <p:cNvSpPr/>
+          <p:nvPr/>
+        </p:nvSpPr>
+        <p:spPr>
+          <a:xfrm>
+            <a:off x="7168896" y="4581144"/>
+            <a:ext cx="4071823" cy="384048"/>
+          </a:xfrm>
+          <a:prstGeom prst="rect">
+            <a:avLst/>
+          </a:prstGeom>
+          <a:noFill/>
+          <a:ln/>
+        </p:spPr>
+        <p:txBody>
+          <a:bodyPr wrap="square" lIns="0" tIns="0" rIns="0" bIns="0" rtlCol="0" anchor="ctr"/>
+          <a:lstStyle/>
+          <a:p>
+            <a:pPr indent="0" marL="0">
+              <a:buNone/>
+            </a:pPr>
+            <a:r>
+              <a:rPr lang="en-US" sz="1600" dirty="0">
+                <a:solidFill>
+                  <a:srgbClr val="25292C"/>
+                </a:solidFill>
+                <a:latin typeface="Jost" pitchFamily="34" charset="0"/>
+                <a:ea typeface="Jost" pitchFamily="34" charset="-122"/>
+                <a:cs typeface="Jost" pitchFamily="34" charset="-120"/>
+              </a:rPr>
+              <a:t>github.com/hackingbiology/biohackit</a:t>
+            </a:r>
+            <a:endParaRPr lang="en-US" sz="1600" dirty="0"/>
+          </a:p>
+        </p:txBody>
+      </p:sp>
+      <p:sp>
+        <p:nvSpPr>
+          <p:cNvPr id="19" name="Text 15"/>
+          <p:cNvSpPr/>
+          <p:nvPr/>
+        </p:nvSpPr>
+        <p:spPr>
+          <a:xfrm>
+            <a:off x="7168896" y="5212080"/>
+            <a:ext cx="4071823" cy="228600"/>
+          </a:xfrm>
+          <a:prstGeom prst="rect">
+            <a:avLst/>
+          </a:prstGeom>
+          <a:noFill/>
+          <a:ln/>
+        </p:spPr>
+        <p:txBody>
+          <a:bodyPr wrap="square" lIns="0" tIns="0" rIns="0" bIns="0" rtlCol="0" anchor="ctr"/>
+          <a:lstStyle/>
+          <a:p>
+            <a:pPr indent="0" marL="0">
+              <a:buNone/>
+            </a:pPr>
+            <a:r>
+              <a:rPr lang="en-US" sz="1000" b="1" spc="250" kern="0" dirty="0">
+                <a:solidFill>
+                  <a:srgbClr val="8B9398"/>
+                </a:solidFill>
+                <a:latin typeface="Jost" pitchFamily="34" charset="0"/>
+                <a:ea typeface="Jost" pitchFamily="34" charset="-122"/>
+                <a:cs typeface="Jost" pitchFamily="34" charset="-120"/>
+              </a:rPr>
+              <a:t>COMMUNITY</a:t>
+            </a:r>
+            <a:endParaRPr lang="en-US" sz="1000" dirty="0"/>
+          </a:p>
+        </p:txBody>
+      </p:sp>
+      <p:sp>
+        <p:nvSpPr>
+          <p:cNvPr id="20" name="Text 16"/>
+          <p:cNvSpPr/>
+          <p:nvPr/>
+        </p:nvSpPr>
+        <p:spPr>
+          <a:xfrm>
+            <a:off x="7168896" y="5449824"/>
+            <a:ext cx="4071823" cy="384048"/>
+          </a:xfrm>
+          <a:prstGeom prst="rect">
+            <a:avLst/>
+          </a:prstGeom>
+          <a:noFill/>
+          <a:ln/>
+        </p:spPr>
+        <p:txBody>
+          <a:bodyPr wrap="square" lIns="0" tIns="0" rIns="0" bIns="0" rtlCol="0" anchor="ctr"/>
+          <a:lstStyle/>
+          <a:p>
+            <a:pPr indent="0" marL="0">
+              <a:buNone/>
+            </a:pPr>
+            <a:r>
+              <a:rPr lang="en-US" sz="1600" dirty="0">
+                <a:solidFill>
+                  <a:srgbClr val="25292C"/>
+                </a:solidFill>
+                <a:latin typeface="Jost" pitchFamily="34" charset="0"/>
+                <a:ea typeface="Jost" pitchFamily="34" charset="-122"/>
+                <a:cs typeface="Jost" pitchFamily="34" charset="-120"/>
+              </a:rPr>
+              <a:t>rapamycin.news</a:t>
+            </a:r>
+            <a:endParaRPr lang="en-US" sz="1600" dirty="0"/>
+          </a:p>
+        </p:txBody>
+      </p:sp>
+      <p:sp>
+        <p:nvSpPr>
+          <p:cNvPr id="21" name="Shape 17"/>
+          <p:cNvSpPr/>
+          <p:nvPr/>
+        </p:nvSpPr>
+        <p:spPr>
+          <a:xfrm>
+            <a:off x="10564063" y="5074920"/>
+            <a:ext cx="566928" cy="566928"/>
+          </a:xfrm>
+          <a:prstGeom prst="ellipse">
+            <a:avLst/>
+          </a:prstGeom>
+          <a:solidFill>
+            <a:srgbClr val="FFFFFF"/>
+          </a:solidFill>
+          <a:ln w="90708">
+            <a:solidFill>
+              <a:srgbClr val="25292C"/>
+            </a:solidFill>
+            <a:prstDash val="solid"/>
+          </a:ln>
+        </p:spPr>
+      </p:sp>
+      <p:sp>
+        <p:nvSpPr>
+          <p:cNvPr id="22" name="Shape 18"/>
+          <p:cNvSpPr/>
+          <p:nvPr/>
+        </p:nvSpPr>
+        <p:spPr>
+          <a:xfrm>
+            <a:off x="10513040" y="5732556"/>
+            <a:ext cx="668975" cy="90708"/>
+          </a:xfrm>
+          <a:prstGeom prst="roundRect">
+            <a:avLst>
+              <a:gd name="adj" fmla="val 50000"/>
+            </a:avLst>
+          </a:prstGeom>
+          <a:solidFill>
+            <a:srgbClr val="0C877A"/>
+          </a:solidFill>
+          <a:ln w="3175">
+            <a:solidFill>
+              <a:srgbClr val="0C877A"/>
+            </a:solidFill>
+            <a:prstDash val="solid"/>
+          </a:ln>
+        </p:spPr>
+      </p:sp>
+    </p:spTree>
+  </p:cSld>
+  <p:clrMapOvr>
+    <a:masterClrMapping/>
+  </p:clrMapOvr>
+</p:sld>
+</file>
+
+<file path=ppt/slides/slide18.xml><?xml version="1.0" encoding="utf-8"?>
+<p:sld xmlns:a="http://schemas.openxmlformats.org/drawingml/2006/main" xmlns:r="http://schemas.openxmlformats.org/officeDocument/2006/relationships" xmlns:p="http://schemas.openxmlformats.org/presentationml/2006/main">
+  <p:cSld name="Slide 18">
+    <p:bg>
+      <p:bgPr>
+        <a:solidFill>
+          <a:srgbClr val="FFFFFF"/>
+        </a:solidFill>
+      </p:bgPr>
+    </p:bg>
+    <p:spTree>
+      <p:nvGrpSpPr>
+        <p:cNvPr id="1" name=""/>
+        <p:cNvGrpSpPr/>
+        <p:nvPr/>
+      </p:nvGrpSpPr>
+      <p:grpSpPr>
+        <a:xfrm>
+          <a:off x="0" y="0"/>
+          <a:ext cx="0" cy="0"/>
+          <a:chOff x="0" y="0"/>
+          <a:chExt cx="0" cy="0"/>
+        </a:xfrm>
+      </p:grpSpPr>
+      <p:sp>
+        <p:nvSpPr>
+          <p:cNvPr id="2" name="Text 0"/>
+          <p:cNvSpPr/>
+          <p:nvPr/>
+        </p:nvSpPr>
+        <p:spPr>
+          <a:xfrm>
             <a:off x="658368" y="1097280"/>
             <a:ext cx="10874959" cy="274320"/>
           </a:xfrm>

</xml_diff>